<commit_message>
fix: omit ZIP directory entries from OPC packages
</commit_message>
<xml_diff>
--- a/test/fixtures/repair/empty-cnvid.pptx
+++ b/test/fixtures/repair/empty-cnvid.pptx
@@ -803,7 +803,7 @@
       </p:grpSpPr>
       <p:sp>
         <p:nvSpPr>
-          <p:cNvPr id="3" name="Text 0"/>
+          <p:cNvPr id="" name="Text 0"/>
           <p:cNvSpPr/>
           <p:nvPr/>
         </p:nvSpPr>
@@ -839,7 +839,7 @@
       </p:sp>
       <p:sp>
         <p:nvSpPr>
-          <p:cNvPr id="4" name="Shape 1"/>
+          <p:cNvPr id="3" name="Shape 1"/>
           <p:cNvSpPr/>
           <p:nvPr/>
         </p:nvSpPr>
@@ -866,14 +866,14 @@
       </p:sp>
       <p:graphicFrame>
         <p:nvGraphicFramePr>
-          <p:cNvPr id="" name="Table 0"/>
+          <p:cNvPr id="4" name="Table 0"/>
           <p:cNvGraphicFramePr>
             <a:graphicFrameLocks noGrp="1"/>
           </p:cNvGraphicFramePr>
           <p:nvPr>
             <p:extLst>
               <p:ext uri="{D42A27DB-BD31-4B8C-83A1-F6EECF244321}">
-                <p14:modId xmlns:p14="http://schemas.microsoft.com/office/powerpoint/2010/main" val="1579011938"/>
+                <p14:modId xmlns:p14="http://schemas.microsoft.com/office/powerpoint/2010/main" val="1579011937"/>
               </p:ext>
             </p:extLst>
           </p:nvPr>
@@ -1036,7 +1036,7 @@
       </p:graphicFrame>
       <p:graphicFrame>
         <p:nvGraphicFramePr>
-          <p:cNvPr id="6" name="Chart 0" descr=""/>
+          <p:cNvPr id="5" name="Chart 0"/>
           <p:cNvGraphicFramePr/>
           <p:nvPr/>
         </p:nvGraphicFramePr>

</xml_diff>